<commit_message>
pitch: apply slide content updates
Slide 1: org·name format, no [Sensor expert]
Slide 2: Fischereiverein See+Gaster, Critical period sub-line,
         pain points 1-2-3 order fixed, target text updated
Slide 3: Fish relocation (not relocate)
Slide 4: Fischereiverein See+Gaster, no novel sensor line
Slide 5: AWEL row, no 18 notebooks, full org name for Patrick
</commit_message>
<xml_diff>
--- a/AareML_Sandbox_Pitch.pptx
+++ b/AareML_Sandbox_Pitch.pptx
@@ -1493,7 +1493,7 @@
                 <a:ea typeface="Calibri" pitchFamily="34" charset="-122"/>
                 <a:cs typeface="Calibri" pitchFamily="34" charset="-120"/>
               </a:rPr>
-              <a:t>Thiago Nascimento (Eawag) · Patrick Hager (Fischerei) · [Sensor expert]</a:t>
+              <a:t>Eawag · Thiago Nascimento · Fischereiverein See + Gaster · Patrick Hager</a:t>
             </a:r>
             <a:endParaRPr lang="en-US" sz="1300" dirty="0"/>
           </a:p>
@@ -1643,7 +1643,7 @@
               <a:buNone/>
             </a:pPr>
             <a:r>
-              <a:rPr lang="en-US" sz="1300" i="1" dirty="0">
+              <a:rPr lang="en-US" sz="1200" i="1" dirty="0">
                 <a:solidFill>
                   <a:srgbClr val="BCE2E7"/>
                 </a:solidFill>
@@ -1651,7 +1651,7 @@
                 <a:ea typeface="Calibri" pitchFamily="34" charset="-122"/>
                 <a:cs typeface="Calibri" pitchFamily="34" charset="-120"/>
               </a:rPr>
-              <a:t>— Patrick Hager, President, oldest Swiss fishery</a:t>
+              <a:t>— Patrick Hager  |  Fischereiverein See + Gaster</a:t>
             </a:r>
             <a:endParaRPr lang="en-US" sz="2000" dirty="0"/>
           </a:p>
@@ -1922,7 +1922,46 @@
       </p:sp>
       <p:sp>
         <p:nvSpPr>
-          <p:cNvPr id="11" name="Shape 9"/>
+          <p:cNvPr id="11" name="Text 9"/>
+          <p:cNvSpPr/>
+          <p:nvPr/>
+        </p:nvSpPr>
+        <p:spPr>
+          <a:xfrm>
+            <a:off x="5486400" y="1508760"/>
+            <a:ext cx="3108960" cy="320040"/>
+          </a:xfrm>
+          <a:prstGeom prst="rect">
+            <a:avLst/>
+          </a:prstGeom>
+          <a:noFill/>
+          <a:ln/>
+        </p:spPr>
+        <p:txBody>
+          <a:bodyPr wrap="square" lIns="0" tIns="0" rIns="0" bIns="0" rtlCol="0" anchor="t"/>
+          <a:lstStyle/>
+          <a:p>
+            <a:pPr algn="l" indent="0" marL="0">
+              <a:buNone/>
+            </a:pPr>
+            <a:r>
+              <a:rPr lang="en-US" sz="1200" i="1" dirty="0">
+                <a:solidFill>
+                  <a:srgbClr val="7A7974"/>
+                </a:solidFill>
+                <a:latin typeface="Calibri" pitchFamily="34" charset="0"/>
+                <a:ea typeface="Calibri" pitchFamily="34" charset="-122"/>
+                <a:cs typeface="Calibri" pitchFamily="34" charset="-120"/>
+              </a:rPr>
+              <a:t>Critical period: mid June – end of August</a:t>
+            </a:r>
+            <a:endParaRPr lang="en-US" sz="1200" dirty="0"/>
+          </a:p>
+        </p:txBody>
+      </p:sp>
+      <p:sp>
+        <p:nvSpPr>
+          <p:cNvPr id="12" name="Shape 10"/>
           <p:cNvSpPr/>
           <p:nvPr/>
         </p:nvSpPr>
@@ -1942,7 +1981,7 @@
       </p:sp>
       <p:sp>
         <p:nvSpPr>
-          <p:cNvPr id="12" name="Text 10"/>
+          <p:cNvPr id="13" name="Text 11"/>
           <p:cNvSpPr/>
           <p:nvPr/>
         </p:nvSpPr>
@@ -2001,7 +2040,7 @@
                 <a:ea typeface="Calibri" pitchFamily="34" charset="-122"/>
                 <a:cs typeface="Calibri" pitchFamily="34" charset="-120"/>
               </a:rPr>
-              <a:t>Target: 7 days automated</a:t>
+              <a:t>Target: automated alert, 7 days in advance</a:t>
             </a:r>
             <a:endParaRPr lang="en-US" sz="1500" dirty="0"/>
           </a:p>
@@ -2384,7 +2423,7 @@
                 <a:ea typeface="Calibri" pitchFamily="34" charset="-122"/>
                 <a:cs typeface="Calibri" pitchFamily="34" charset="-120"/>
               </a:rPr>
-              <a:t>Fish relocate within 15-minute window before conditions turn critical</a:t>
+              <a:t>Fish relocation within 15-minute window before conditions turn critical</a:t>
             </a:r>
             <a:endParaRPr lang="en-US" sz="1450" dirty="0"/>
           </a:p>
@@ -2627,30 +2666,7 @@
                 <a:ea typeface="Calibri" pitchFamily="34" charset="-122"/>
                 <a:cs typeface="Calibri" pitchFamily="34" charset="-120"/>
               </a:rPr>
-              <a:t>✓  Domain partner — Patrick's fishery (operational validation)</a:t>
-            </a:r>
-            <a:endParaRPr lang="en-US" sz="1400" dirty="0"/>
-          </a:p>
-          <a:p>
-            <a:pPr algn="l" indent="0" marL="0">
-              <a:lnSpc>
-                <a:spcPts val="1800"/>
-              </a:lnSpc>
-              <a:spcAft>
-                <a:spcPts val="800"/>
-              </a:spcAft>
-              <a:buNone/>
-            </a:pPr>
-            <a:r>
-              <a:rPr lang="en-US" sz="1400" dirty="0">
-                <a:solidFill>
-                  <a:srgbClr val="28251D"/>
-                </a:solidFill>
-                <a:latin typeface="Calibri" pitchFamily="34" charset="0"/>
-                <a:ea typeface="Calibri" pitchFamily="34" charset="-122"/>
-                <a:cs typeface="Calibri" pitchFamily="34" charset="-120"/>
-              </a:rPr>
-              <a:t>✓  Novel sensor partner — floating sensor prototype</a:t>
+              <a:t>✓  Domain partner — Fischereiverein See + Gaster (operational validation)</a:t>
             </a:r>
             <a:endParaRPr lang="en-US" sz="1400" dirty="0"/>
           </a:p>
@@ -3043,7 +3059,7 @@
                 <a:ea typeface="Calibri" pitchFamily="34" charset="-122"/>
                 <a:cs typeface="Calibri" pitchFamily="34" charset="-120"/>
               </a:rPr>
-              <a:t>AareML prototype, 18 notebooks, UBELIX HPC</a:t>
+              <a:t>AareML prototype, UBELIX HPC</a:t>
             </a:r>
             <a:endParaRPr lang="en-US" sz="1300" dirty="0"/>
           </a:p>
@@ -3253,7 +3269,7 @@
                 <a:ea typeface="Trebuchet MS" pitchFamily="34" charset="-122"/>
                 <a:cs typeface="Trebuchet MS" pitchFamily="34" charset="-120"/>
               </a:rPr>
-              <a:t>Fischerei</a:t>
+              <a:t>Fischereiverein See + Gaster</a:t>
             </a:r>
             <a:endParaRPr lang="en-US" sz="1900" dirty="0"/>
           </a:p>
@@ -3295,7 +3311,7 @@
                 <a:ea typeface="Calibri" pitchFamily="34" charset="-122"/>
                 <a:cs typeface="Calibri" pitchFamily="34" charset="-120"/>
               </a:rPr>
-              <a:t>Domain expertise, go/no-go rescue ops, oldest Swiss fishery</a:t>
+              <a:t>Domain expertise, go/no-go rescue ops</a:t>
             </a:r>
             <a:endParaRPr lang="en-US" sz="1300" dirty="0"/>
           </a:p>
@@ -3318,7 +3334,7 @@
             </a:avLst>
           </a:prstGeom>
           <a:solidFill>
-            <a:srgbClr val="7A7974"/>
+            <a:srgbClr val="0C4E54"/>
           </a:solidFill>
           <a:ln/>
         </p:spPr>
@@ -3359,7 +3375,7 @@
                 <a:ea typeface="Trebuchet MS" pitchFamily="34" charset="-122"/>
                 <a:cs typeface="Trebuchet MS" pitchFamily="34" charset="-120"/>
               </a:rPr>
-              <a:t>[Sensor Expert]</a:t>
+              <a:t>AWEL</a:t>
             </a:r>
             <a:endParaRPr lang="en-US" sz="1900" dirty="0"/>
           </a:p>
@@ -3379,7 +3395,7 @@
                 <a:ea typeface="Trebuchet MS" pitchFamily="34" charset="-122"/>
                 <a:cs typeface="Trebuchet MS" pitchFamily="34" charset="-120"/>
               </a:rPr>
-              <a:t>Novel Sensor</a:t>
+              <a:t>Canton Zurich</a:t>
             </a:r>
             <a:endParaRPr lang="en-US" sz="1900" dirty="0"/>
           </a:p>
@@ -3421,7 +3437,7 @@
                 <a:ea typeface="Calibri" pitchFamily="34" charset="-122"/>
                 <a:cs typeface="Calibri" pitchFamily="34" charset="-120"/>
               </a:rPr>
-              <a:t>New floating depth-aware temperature sensor prototype for critical river points</a:t>
+              <a:t>Water quality monitoring authority, 150+ cantonal sites</a:t>
             </a:r>
             <a:endParaRPr lang="en-US" sz="1300" dirty="0"/>
           </a:p>

</xml_diff>

<commit_message>
revert pitch: roll back to pre-content-update version (031403b)
</commit_message>
<xml_diff>
--- a/AareML_Sandbox_Pitch.pptx
+++ b/AareML_Sandbox_Pitch.pptx
@@ -1493,7 +1493,7 @@
                 <a:ea typeface="Calibri" pitchFamily="34" charset="-122"/>
                 <a:cs typeface="Calibri" pitchFamily="34" charset="-120"/>
               </a:rPr>
-              <a:t>Eawag · Thiago Nascimento · Fischereiverein See + Gaster · Patrick Hager</a:t>
+              <a:t>Thiago Nascimento (Eawag) · Patrick Hager (Fischerei) · [Sensor expert]</a:t>
             </a:r>
             <a:endParaRPr lang="en-US" sz="1300" dirty="0"/>
           </a:p>
@@ -1643,7 +1643,7 @@
               <a:buNone/>
             </a:pPr>
             <a:r>
-              <a:rPr lang="en-US" sz="1200" i="1" dirty="0">
+              <a:rPr lang="en-US" sz="1300" i="1" dirty="0">
                 <a:solidFill>
                   <a:srgbClr val="BCE2E7"/>
                 </a:solidFill>
@@ -1651,7 +1651,7 @@
                 <a:ea typeface="Calibri" pitchFamily="34" charset="-122"/>
                 <a:cs typeface="Calibri" pitchFamily="34" charset="-120"/>
               </a:rPr>
-              <a:t>— Patrick Hager  |  Fischereiverein See + Gaster</a:t>
+              <a:t>— Patrick Hager, President, oldest Swiss fishery</a:t>
             </a:r>
             <a:endParaRPr lang="en-US" sz="2000" dirty="0"/>
           </a:p>
@@ -1922,125 +1922,86 @@
       </p:sp>
       <p:sp>
         <p:nvSpPr>
-          <p:cNvPr id="11" name="Text 9"/>
-          <p:cNvSpPr/>
-          <p:nvPr/>
-        </p:nvSpPr>
-        <p:spPr>
-          <a:xfrm>
-            <a:off x="5486400" y="1508760"/>
-            <a:ext cx="3108960" cy="320040"/>
-          </a:xfrm>
-          <a:prstGeom prst="rect">
-            <a:avLst/>
-          </a:prstGeom>
-          <a:noFill/>
-          <a:ln/>
-        </p:spPr>
-        <p:txBody>
-          <a:bodyPr wrap="square" lIns="0" tIns="0" rIns="0" bIns="0" rtlCol="0" anchor="t"/>
-          <a:lstStyle/>
-          <a:p>
-            <a:pPr algn="l" indent="0" marL="0">
-              <a:buNone/>
-            </a:pPr>
-            <a:r>
-              <a:rPr lang="en-US" sz="1200" i="1" dirty="0">
-                <a:solidFill>
-                  <a:srgbClr val="7A7974"/>
+          <p:cNvPr id="11" name="Shape 9"/>
+          <p:cNvSpPr/>
+          <p:nvPr/>
+        </p:nvSpPr>
+        <p:spPr>
+          <a:xfrm>
+            <a:off x="548640" y="4160520"/>
+            <a:ext cx="8046720" cy="548640"/>
+          </a:xfrm>
+          <a:prstGeom prst="rect">
+            <a:avLst/>
+          </a:prstGeom>
+          <a:solidFill>
+            <a:srgbClr val="0C4E54"/>
+          </a:solidFill>
+          <a:ln/>
+        </p:spPr>
+      </p:sp>
+      <p:sp>
+        <p:nvSpPr>
+          <p:cNvPr id="12" name="Text 10"/>
+          <p:cNvSpPr/>
+          <p:nvPr/>
+        </p:nvSpPr>
+        <p:spPr>
+          <a:xfrm>
+            <a:off x="548640" y="4160520"/>
+            <a:ext cx="8046720" cy="548640"/>
+          </a:xfrm>
+          <a:prstGeom prst="rect">
+            <a:avLst/>
+          </a:prstGeom>
+          <a:noFill/>
+          <a:ln/>
+        </p:spPr>
+        <p:txBody>
+          <a:bodyPr wrap="square" lIns="0" tIns="0" rIns="0" bIns="0" rtlCol="0" anchor="ctr"/>
+          <a:lstStyle/>
+          <a:p>
+            <a:pPr algn="ctr" indent="0" marL="0">
+              <a:buNone/>
+            </a:pPr>
+            <a:r>
+              <a:rPr lang="en-US" sz="1500" b="1" dirty="0">
+                <a:solidFill>
+                  <a:srgbClr val="E89AA3"/>
                 </a:solidFill>
                 <a:latin typeface="Calibri" pitchFamily="34" charset="0"/>
                 <a:ea typeface="Calibri" pitchFamily="34" charset="-122"/>
                 <a:cs typeface="Calibri" pitchFamily="34" charset="-120"/>
               </a:rPr>
-              <a:t>Critical period: mid June – end of August</a:t>
-            </a:r>
-            <a:endParaRPr lang="en-US" sz="1200" dirty="0"/>
-          </a:p>
-        </p:txBody>
-      </p:sp>
-      <p:sp>
-        <p:nvSpPr>
-          <p:cNvPr id="12" name="Shape 10"/>
-          <p:cNvSpPr/>
-          <p:nvPr/>
-        </p:nvSpPr>
-        <p:spPr>
-          <a:xfrm>
-            <a:off x="548640" y="4160520"/>
-            <a:ext cx="8046720" cy="548640"/>
-          </a:xfrm>
-          <a:prstGeom prst="rect">
-            <a:avLst/>
-          </a:prstGeom>
-          <a:solidFill>
-            <a:srgbClr val="0C4E54"/>
-          </a:solidFill>
-          <a:ln/>
-        </p:spPr>
-      </p:sp>
-      <p:sp>
-        <p:nvSpPr>
-          <p:cNvPr id="13" name="Text 11"/>
-          <p:cNvSpPr/>
-          <p:nvPr/>
-        </p:nvSpPr>
-        <p:spPr>
-          <a:xfrm>
-            <a:off x="548640" y="4160520"/>
-            <a:ext cx="8046720" cy="548640"/>
-          </a:xfrm>
-          <a:prstGeom prst="rect">
-            <a:avLst/>
-          </a:prstGeom>
-          <a:noFill/>
-          <a:ln/>
-        </p:spPr>
-        <p:txBody>
-          <a:bodyPr wrap="square" lIns="0" tIns="0" rIns="0" bIns="0" rtlCol="0" anchor="ctr"/>
-          <a:lstStyle/>
-          <a:p>
+              <a:t>Today: daily manual checks → 24h rescue decision</a:t>
+            </a:r>
             <a:pPr algn="ctr" indent="0" marL="0">
               <a:buNone/>
             </a:pPr>
             <a:r>
-              <a:rPr lang="en-US" sz="1500" b="1" dirty="0">
-                <a:solidFill>
-                  <a:srgbClr val="E89AA3"/>
+              <a:rPr lang="en-US" sz="1500" dirty="0">
+                <a:solidFill>
+                  <a:srgbClr val="7A7974"/>
                 </a:solidFill>
                 <a:latin typeface="Calibri" pitchFamily="34" charset="0"/>
                 <a:ea typeface="Calibri" pitchFamily="34" charset="-122"/>
                 <a:cs typeface="Calibri" pitchFamily="34" charset="-120"/>
               </a:rPr>
-              <a:t>Today: daily manual checks → 24h rescue decision</a:t>
+              <a:t>   ·   </a:t>
             </a:r>
             <a:pPr algn="ctr" indent="0" marL="0">
               <a:buNone/>
             </a:pPr>
             <a:r>
-              <a:rPr lang="en-US" sz="1500" dirty="0">
-                <a:solidFill>
-                  <a:srgbClr val="7A7974"/>
+              <a:rPr lang="en-US" sz="1500" b="1" dirty="0">
+                <a:solidFill>
+                  <a:srgbClr val="BCE2E7"/>
                 </a:solidFill>
                 <a:latin typeface="Calibri" pitchFamily="34" charset="0"/>
                 <a:ea typeface="Calibri" pitchFamily="34" charset="-122"/>
                 <a:cs typeface="Calibri" pitchFamily="34" charset="-120"/>
               </a:rPr>
-              <a:t>   ·   </a:t>
-            </a:r>
-            <a:pPr algn="ctr" indent="0" marL="0">
-              <a:buNone/>
-            </a:pPr>
-            <a:r>
-              <a:rPr lang="en-US" sz="1500" b="1" dirty="0">
-                <a:solidFill>
-                  <a:srgbClr val="BCE2E7"/>
-                </a:solidFill>
-                <a:latin typeface="Calibri" pitchFamily="34" charset="0"/>
-                <a:ea typeface="Calibri" pitchFamily="34" charset="-122"/>
-                <a:cs typeface="Calibri" pitchFamily="34" charset="-120"/>
-              </a:rPr>
-              <a:t>Target: automated alert, 7 days in advance</a:t>
+              <a:t>Target: 7 days automated</a:t>
             </a:r>
             <a:endParaRPr lang="en-US" sz="1500" dirty="0"/>
           </a:p>
@@ -2423,7 +2384,7 @@
                 <a:ea typeface="Calibri" pitchFamily="34" charset="-122"/>
                 <a:cs typeface="Calibri" pitchFamily="34" charset="-120"/>
               </a:rPr>
-              <a:t>Fish relocation within 15-minute window before conditions turn critical</a:t>
+              <a:t>Fish relocate within 15-minute window before conditions turn critical</a:t>
             </a:r>
             <a:endParaRPr lang="en-US" sz="1450" dirty="0"/>
           </a:p>
@@ -2666,7 +2627,30 @@
                 <a:ea typeface="Calibri" pitchFamily="34" charset="-122"/>
                 <a:cs typeface="Calibri" pitchFamily="34" charset="-120"/>
               </a:rPr>
-              <a:t>✓  Domain partner — Fischereiverein See + Gaster (operational validation)</a:t>
+              <a:t>✓  Domain partner — Patrick's fishery (operational validation)</a:t>
+            </a:r>
+            <a:endParaRPr lang="en-US" sz="1400" dirty="0"/>
+          </a:p>
+          <a:p>
+            <a:pPr algn="l" indent="0" marL="0">
+              <a:lnSpc>
+                <a:spcPts val="1800"/>
+              </a:lnSpc>
+              <a:spcAft>
+                <a:spcPts val="800"/>
+              </a:spcAft>
+              <a:buNone/>
+            </a:pPr>
+            <a:r>
+              <a:rPr lang="en-US" sz="1400" dirty="0">
+                <a:solidFill>
+                  <a:srgbClr val="28251D"/>
+                </a:solidFill>
+                <a:latin typeface="Calibri" pitchFamily="34" charset="0"/>
+                <a:ea typeface="Calibri" pitchFamily="34" charset="-122"/>
+                <a:cs typeface="Calibri" pitchFamily="34" charset="-120"/>
+              </a:rPr>
+              <a:t>✓  Novel sensor partner — floating sensor prototype</a:t>
             </a:r>
             <a:endParaRPr lang="en-US" sz="1400" dirty="0"/>
           </a:p>
@@ -3059,7 +3043,7 @@
                 <a:ea typeface="Calibri" pitchFamily="34" charset="-122"/>
                 <a:cs typeface="Calibri" pitchFamily="34" charset="-120"/>
               </a:rPr>
-              <a:t>AareML prototype, UBELIX HPC</a:t>
+              <a:t>AareML prototype, 18 notebooks, UBELIX HPC</a:t>
             </a:r>
             <a:endParaRPr lang="en-US" sz="1300" dirty="0"/>
           </a:p>
@@ -3269,7 +3253,7 @@
                 <a:ea typeface="Trebuchet MS" pitchFamily="34" charset="-122"/>
                 <a:cs typeface="Trebuchet MS" pitchFamily="34" charset="-120"/>
               </a:rPr>
-              <a:t>Fischereiverein See + Gaster</a:t>
+              <a:t>Fischerei</a:t>
             </a:r>
             <a:endParaRPr lang="en-US" sz="1900" dirty="0"/>
           </a:p>
@@ -3311,7 +3295,7 @@
                 <a:ea typeface="Calibri" pitchFamily="34" charset="-122"/>
                 <a:cs typeface="Calibri" pitchFamily="34" charset="-120"/>
               </a:rPr>
-              <a:t>Domain expertise, go/no-go rescue ops</a:t>
+              <a:t>Domain expertise, go/no-go rescue ops, oldest Swiss fishery</a:t>
             </a:r>
             <a:endParaRPr lang="en-US" sz="1300" dirty="0"/>
           </a:p>
@@ -3334,7 +3318,7 @@
             </a:avLst>
           </a:prstGeom>
           <a:solidFill>
-            <a:srgbClr val="0C4E54"/>
+            <a:srgbClr val="7A7974"/>
           </a:solidFill>
           <a:ln/>
         </p:spPr>
@@ -3375,7 +3359,7 @@
                 <a:ea typeface="Trebuchet MS" pitchFamily="34" charset="-122"/>
                 <a:cs typeface="Trebuchet MS" pitchFamily="34" charset="-120"/>
               </a:rPr>
-              <a:t>AWEL</a:t>
+              <a:t>[Sensor Expert]</a:t>
             </a:r>
             <a:endParaRPr lang="en-US" sz="1900" dirty="0"/>
           </a:p>
@@ -3395,7 +3379,7 @@
                 <a:ea typeface="Trebuchet MS" pitchFamily="34" charset="-122"/>
                 <a:cs typeface="Trebuchet MS" pitchFamily="34" charset="-120"/>
               </a:rPr>
-              <a:t>Canton Zurich</a:t>
+              <a:t>Novel Sensor</a:t>
             </a:r>
             <a:endParaRPr lang="en-US" sz="1900" dirty="0"/>
           </a:p>
@@ -3437,7 +3421,7 @@
                 <a:ea typeface="Calibri" pitchFamily="34" charset="-122"/>
                 <a:cs typeface="Calibri" pitchFamily="34" charset="-120"/>
               </a:rPr>
-              <a:t>Water quality monitoring authority, 150+ cantonal sites</a:t>
+              <a:t>New floating depth-aware temperature sensor prototype for critical river points</a:t>
             </a:r>
             <a:endParaRPr lang="en-US" sz="1300" dirty="0"/>
           </a:p>

</xml_diff>

<commit_message>
pitch: apply content updates (names, Fischereiverein, AWEL, Critical period)
Slide 1: T.N. & O.N. → Tatyana Nikolayeva & Olga Nikolayeva, removed team line
Slide 2: oldest Swiss fishery → Fischereiverein See + Gaster, Critical period
         sub-line added, Target: automated alert 7 days in advance
Slide 3: Fish relocate → Fish relocation
Slide 4: Patrick's fishery → Fischereiverein See+Gaster, removed Novel sensor
Slide 5: T.N.&O.N. → Tatyana & Olga, removed 18 notebooks, Fischerei →
         Fischereiverein See+Gaster, removed oldest Swiss fishery,
         Sensor Expert → AWEL / Canton Zurich
</commit_message>
<xml_diff>
--- a/AareML_Sandbox_Pitch.pptx
+++ b/AareML_Sandbox_Pitch.pptx
@@ -1473,27 +1473,7 @@
                 <a:ea typeface="Calibri" pitchFamily="34" charset="-122"/>
                 <a:cs typeface="Calibri" pitchFamily="34" charset="-120"/>
               </a:rPr>
-              <a:t>T.N. &amp; O.N. — AI &amp; ML</a:t>
-            </a:r>
-            <a:endParaRPr lang="en-US" sz="1300" dirty="0"/>
-          </a:p>
-          <a:p>
-            <a:pPr algn="l" indent="0" marL="0">
-              <a:lnSpc>
-                <a:spcPts val="2000"/>
-              </a:lnSpc>
-              <a:buNone/>
-            </a:pPr>
-            <a:r>
-              <a:rPr lang="en-US" sz="1300" dirty="0">
-                <a:solidFill>
-                  <a:srgbClr val="9FB8BB"/>
-                </a:solidFill>
-                <a:latin typeface="Calibri" pitchFamily="34" charset="0"/>
-                <a:ea typeface="Calibri" pitchFamily="34" charset="-122"/>
-                <a:cs typeface="Calibri" pitchFamily="34" charset="-120"/>
-              </a:rPr>
-              <a:t>Thiago Nascimento (Eawag) · Patrick Hager (Fischerei) · [Sensor expert]</a:t>
+              <a:t>Tatyana Nikolayeva &amp; Olga Nikolayeva</a:t>
             </a:r>
             <a:endParaRPr lang="en-US" sz="1300" dirty="0"/>
           </a:p>
@@ -1643,7 +1623,7 @@
               <a:buNone/>
             </a:pPr>
             <a:r>
-              <a:rPr lang="en-US" sz="1300" i="1" dirty="0">
+              <a:rPr lang="en-US" sz="1100" i="1" dirty="0">
                 <a:solidFill>
                   <a:srgbClr val="BCE2E7"/>
                 </a:solidFill>
@@ -1651,7 +1631,7 @@
                 <a:ea typeface="Calibri" pitchFamily="34" charset="-122"/>
                 <a:cs typeface="Calibri" pitchFamily="34" charset="-120"/>
               </a:rPr>
-              <a:t>— Patrick Hager, President, oldest Swiss fishery</a:t>
+              <a:t>— Patrick Hager, President, Fischereiverein See + Gaster</a:t>
             </a:r>
             <a:endParaRPr lang="en-US" sz="2000" dirty="0"/>
           </a:p>
@@ -1736,6 +1716,29 @@
             </a:r>
             <a:endParaRPr lang="en-US" sz="1500" dirty="0"/>
           </a:p>
+          <a:p>
+            <a:pPr algn="l" indent="0" marL="0">
+              <a:lnSpc>
+                <a:spcPts val="1900"/>
+              </a:lnSpc>
+              <a:buNone/>
+            </a:pPr>
+            <a:endParaRPr lang="en-US" sz="1500" dirty="0"/>
+            <a:r>
+              <a:rPr lang="en-US" sz="1100" dirty="0" i="1">
+                <a:solidFill>
+                  <a:srgbClr val="28251D"/>
+                </a:solidFill>
+                <a:latin typeface="Calibri" pitchFamily="34" charset="0"/>
+                <a:ea typeface="Calibri" pitchFamily="34" charset="-122"/>
+                <a:cs typeface="Calibri" pitchFamily="34" charset="-120"/>
+                <a:solidFill>
+                  <a:srgbClr val="7A7974"/>
+                </a:solidFill>
+              </a:rPr>
+              <a:t>Critical period: mid June – end of August</a:t>
+            </a:r>
+          </a:p>
         </p:txBody>
       </p:sp>
       <p:sp>
@@ -1973,7 +1976,7 @@
                 <a:ea typeface="Calibri" pitchFamily="34" charset="-122"/>
                 <a:cs typeface="Calibri" pitchFamily="34" charset="-120"/>
               </a:rPr>
-              <a:t>Today: daily manual checks → 24h rescue decision</a:t>
+              <a:t>Today: daily manual checks → 24h rescue decision   ·   Target: automated alert, 7 days in advance</a:t>
             </a:r>
             <a:pPr algn="ctr" indent="0" marL="0">
               <a:buNone/>
@@ -1987,7 +1990,7 @@
                 <a:ea typeface="Calibri" pitchFamily="34" charset="-122"/>
                 <a:cs typeface="Calibri" pitchFamily="34" charset="-120"/>
               </a:rPr>
-              <a:t>   ·   </a:t>
+              <a:t/>
             </a:r>
             <a:pPr algn="ctr" indent="0" marL="0">
               <a:buNone/>
@@ -2001,7 +2004,7 @@
                 <a:ea typeface="Calibri" pitchFamily="34" charset="-122"/>
                 <a:cs typeface="Calibri" pitchFamily="34" charset="-120"/>
               </a:rPr>
-              <a:t>Target: 7 days automated</a:t>
+              <a:t/>
             </a:r>
             <a:endParaRPr lang="en-US" sz="1500" dirty="0"/>
           </a:p>
@@ -2384,7 +2387,7 @@
                 <a:ea typeface="Calibri" pitchFamily="34" charset="-122"/>
                 <a:cs typeface="Calibri" pitchFamily="34" charset="-120"/>
               </a:rPr>
-              <a:t>Fish relocate within 15-minute window before conditions turn critical</a:t>
+              <a:t>Fish relocation within 15-minute window before conditions turn critical</a:t>
             </a:r>
             <a:endParaRPr lang="en-US" sz="1450" dirty="0"/>
           </a:p>
@@ -2627,30 +2630,7 @@
                 <a:ea typeface="Calibri" pitchFamily="34" charset="-122"/>
                 <a:cs typeface="Calibri" pitchFamily="34" charset="-120"/>
               </a:rPr>
-              <a:t>✓  Domain partner — Patrick's fishery (operational validation)</a:t>
-            </a:r>
-            <a:endParaRPr lang="en-US" sz="1400" dirty="0"/>
-          </a:p>
-          <a:p>
-            <a:pPr algn="l" indent="0" marL="0">
-              <a:lnSpc>
-                <a:spcPts val="1800"/>
-              </a:lnSpc>
-              <a:spcAft>
-                <a:spcPts val="800"/>
-              </a:spcAft>
-              <a:buNone/>
-            </a:pPr>
-            <a:r>
-              <a:rPr lang="en-US" sz="1400" dirty="0">
-                <a:solidFill>
-                  <a:srgbClr val="28251D"/>
-                </a:solidFill>
-                <a:latin typeface="Calibri" pitchFamily="34" charset="0"/>
-                <a:ea typeface="Calibri" pitchFamily="34" charset="-122"/>
-                <a:cs typeface="Calibri" pitchFamily="34" charset="-120"/>
-              </a:rPr>
-              <a:t>✓  Novel sensor partner — floating sensor prototype</a:t>
+              <a:t>✓  Domain partner — Fischereiverein See + Gaster (operational validation)</a:t>
             </a:r>
             <a:endParaRPr lang="en-US" sz="1400" dirty="0"/>
           </a:p>
@@ -2981,7 +2961,7 @@
                 <a:ea typeface="Trebuchet MS" pitchFamily="34" charset="-122"/>
                 <a:cs typeface="Trebuchet MS" pitchFamily="34" charset="-120"/>
               </a:rPr>
-              <a:t>T.N. &amp; O.N.</a:t>
+              <a:t>Tatyana &amp; Olga</a:t>
             </a:r>
             <a:endParaRPr lang="en-US" sz="1900" dirty="0"/>
           </a:p>
@@ -3043,7 +3023,7 @@
                 <a:ea typeface="Calibri" pitchFamily="34" charset="-122"/>
                 <a:cs typeface="Calibri" pitchFamily="34" charset="-120"/>
               </a:rPr>
-              <a:t>AareML prototype, 18 notebooks, UBELIX HPC</a:t>
+              <a:t>AareML prototype, UBELIX HPC</a:t>
             </a:r>
             <a:endParaRPr lang="en-US" sz="1300" dirty="0"/>
           </a:p>
@@ -3253,7 +3233,7 @@
                 <a:ea typeface="Trebuchet MS" pitchFamily="34" charset="-122"/>
                 <a:cs typeface="Trebuchet MS" pitchFamily="34" charset="-120"/>
               </a:rPr>
-              <a:t>Fischerei</a:t>
+              <a:t>Fischereiverein See + Gaster</a:t>
             </a:r>
             <a:endParaRPr lang="en-US" sz="1900" dirty="0"/>
           </a:p>
@@ -3295,7 +3275,7 @@
                 <a:ea typeface="Calibri" pitchFamily="34" charset="-122"/>
                 <a:cs typeface="Calibri" pitchFamily="34" charset="-120"/>
               </a:rPr>
-              <a:t>Domain expertise, go/no-go rescue ops, oldest Swiss fishery</a:t>
+              <a:t>Domain expertise, go/no-go rescue ops</a:t>
             </a:r>
             <a:endParaRPr lang="en-US" sz="1300" dirty="0"/>
           </a:p>
@@ -3359,7 +3339,7 @@
                 <a:ea typeface="Trebuchet MS" pitchFamily="34" charset="-122"/>
                 <a:cs typeface="Trebuchet MS" pitchFamily="34" charset="-120"/>
               </a:rPr>
-              <a:t>[Sensor Expert]</a:t>
+              <a:t>AWEL</a:t>
             </a:r>
             <a:endParaRPr lang="en-US" sz="1900" dirty="0"/>
           </a:p>
@@ -3379,7 +3359,7 @@
                 <a:ea typeface="Trebuchet MS" pitchFamily="34" charset="-122"/>
                 <a:cs typeface="Trebuchet MS" pitchFamily="34" charset="-120"/>
               </a:rPr>
-              <a:t>Novel Sensor</a:t>
+              <a:t>Canton Zurich</a:t>
             </a:r>
             <a:endParaRPr lang="en-US" sz="1900" dirty="0"/>
           </a:p>
@@ -3421,7 +3401,7 @@
                 <a:ea typeface="Calibri" pitchFamily="34" charset="-122"/>
                 <a:cs typeface="Calibri" pitchFamily="34" charset="-120"/>
               </a:rPr>
-              <a:t>New floating depth-aware temperature sensor prototype for critical river points</a:t>
+              <a:t>Water quality monitoring authority, 150+ cantonal sites</a:t>
             </a:r>
             <a:endParaRPr lang="en-US" sz="1300" dirty="0"/>
           </a:p>

</xml_diff>